<commit_message>
feat: perbarui narasi target kebutuhan pabrik & generate presentasi PPT ke format PDF
</commit_message>
<xml_diff>
--- a/PAPARAN_ESTIMASI_STRATEGIS_PORTOFOLIO_KEBUN_TMC.pptx
+++ b/PAPARAN_ESTIMASI_STRATEGIS_PORTOFOLIO_KEBUN_TMC.pptx
@@ -1831,7 +1831,7 @@
                 <a:ea typeface="Arial" pitchFamily="34" charset="-122"/>
                 <a:cs typeface="Arial" pitchFamily="34" charset="-120"/>
               </a:rPr>
-              <a:t>Kapasitas Olah Pabrik &amp; Urgensi Pasokan:
+              <a:t>Target Kebutuhan Bahan Baku Operasional Pabrik:
 </a:t>
             </a:r>
             <a:pPr indent="0" marL="0">
@@ -1846,7 +1846,7 @@
                 <a:ea typeface="Arial" pitchFamily="34" charset="-122"/>
                 <a:cs typeface="Arial" pitchFamily="34" charset="-120"/>
               </a:rPr>
-              <a:t>• Pabrik kelapa terpadu TMC memiliki kapasitas olah sebesar </a:t>
+              <a:t>• Target pemenuhan bahan baku operasional pabrik kelapa terpadu TMC ditetapkan sebesar </a:t>
             </a:r>
             <a:pPr indent="0" marL="0">
               <a:buNone/>
@@ -1874,7 +1874,7 @@
                 <a:ea typeface="Arial" pitchFamily="34" charset="-122"/>
                 <a:cs typeface="Arial" pitchFamily="34" charset="-120"/>
               </a:rPr>
-              <a:t> dengan operasional 20 Hari Kerja/bulan (400.000 butir/HK).
+              <a:t> dengan operasional 20 Hari Kerja/bulan (400.000 butir/HK). Angka ini adalah target kebutuhan bahan baku untuk kelancaran pabrik (bukan kapasitas olah yang telah berjalan saat ini).
 </a:t>
             </a:r>
             <a:pPr indent="0" marL="0">

</xml_diff>

<commit_message>
feat: perbarui teks paparan kebutuhan supply kebun 10% dan realisasi hasil panen Blok 1
</commit_message>
<xml_diff>
--- a/PAPARAN_ESTIMASI_STRATEGIS_PORTOFOLIO_KEBUN_TMC.pptx
+++ b/PAPARAN_ESTIMASI_STRATEGIS_PORTOFOLIO_KEBUN_TMC.pptx
@@ -1742,7 +1742,7 @@
                 <a:ea typeface="Arial" pitchFamily="34" charset="-122"/>
                 <a:cs typeface="Arial" pitchFamily="34" charset="-120"/>
               </a:rPr>
-              <a:t>1. Latar Belakang &amp; Mandat Target Pasokan Mandiri 10%</a:t>
+              <a:t>1. Kebutuhan Pasokan Kelapa TMC: Target Supply Kebun Mandiri 10% / Hari</a:t>
             </a:r>
             <a:endParaRPr lang="en-US" sz="1800" dirty="0"/>
           </a:p>
@@ -1779,12 +1779,12 @@
         </p:nvSpPr>
         <p:spPr>
           <a:xfrm>
-            <a:off x="731520" y="1371600"/>
-            <a:ext cx="10698480" cy="1371600"/>
+            <a:off x="731520" y="1325880"/>
+            <a:ext cx="10698480" cy="1508760"/>
           </a:xfrm>
           <a:prstGeom prst="roundRect">
             <a:avLst>
-              <a:gd name="adj" fmla="val 5333"/>
+              <a:gd name="adj" fmla="val 4848"/>
             </a:avLst>
           </a:prstGeom>
           <a:solidFill>
@@ -1806,8 +1806,8 @@
         </p:nvSpPr>
         <p:spPr>
           <a:xfrm>
-            <a:off x="1005840" y="1481328"/>
-            <a:ext cx="10149840" cy="1143000"/>
+            <a:off x="1005840" y="1389888"/>
+            <a:ext cx="10149840" cy="1371600"/>
           </a:xfrm>
           <a:prstGeom prst="rect">
             <a:avLst/>
@@ -1823,7 +1823,35 @@
               <a:buNone/>
             </a:pPr>
             <a:r>
-              <a:rPr lang="en-US" sz="1100" b="1" dirty="0">
+              <a:rPr lang="en-US" sz="950" b="1" dirty="0">
+                <a:solidFill>
+                  <a:srgbClr val="047857"/>
+                </a:solidFill>
+                <a:latin typeface="Arial" pitchFamily="34" charset="0"/>
+                <a:ea typeface="Arial" pitchFamily="34" charset="-122"/>
+                <a:cs typeface="Arial" pitchFamily="34" charset="-120"/>
+              </a:rPr>
+              <a:t>• Target Kebutuhan Produksi Pabrik: </a:t>
+            </a:r>
+            <a:pPr indent="0" marL="0">
+              <a:buNone/>
+            </a:pPr>
+            <a:r>
+              <a:rPr lang="en-US" sz="850" dirty="0">
+                <a:solidFill>
+                  <a:srgbClr val="334155"/>
+                </a:solidFill>
+                <a:latin typeface="Arial" pitchFamily="34" charset="0"/>
+                <a:ea typeface="Arial" pitchFamily="34" charset="-122"/>
+                <a:cs typeface="Arial" pitchFamily="34" charset="-120"/>
+              </a:rPr>
+              <a:t>Kebutuhan bahan baku produksi pabrik pengolahan kelapa terpadu TMC ditetapkan sebesar </a:t>
+            </a:r>
+            <a:pPr indent="0" marL="0">
+              <a:buNone/>
+            </a:pPr>
+            <a:r>
+              <a:rPr lang="en-US" sz="850" b="1" dirty="0">
                 <a:solidFill>
                   <a:srgbClr val="0F172A"/>
                 </a:solidFill>
@@ -1831,14 +1859,42 @@
                 <a:ea typeface="Arial" pitchFamily="34" charset="-122"/>
                 <a:cs typeface="Arial" pitchFamily="34" charset="-120"/>
               </a:rPr>
-              <a:t>Target Kebutuhan Bahan Baku Operasional Pabrik:
+              <a:t>400.000 butir kelapa/hari kerja </a:t>
+            </a:r>
+            <a:pPr indent="0" marL="0">
+              <a:buNone/>
+            </a:pPr>
+            <a:r>
+              <a:rPr lang="en-US" sz="850" dirty="0">
+                <a:solidFill>
+                  <a:srgbClr val="334155"/>
+                </a:solidFill>
+                <a:latin typeface="Arial" pitchFamily="34" charset="0"/>
+                <a:ea typeface="Arial" pitchFamily="34" charset="-122"/>
+                <a:cs typeface="Arial" pitchFamily="34" charset="-120"/>
+              </a:rPr>
+              <a:t>(20 HK/bulan = 8.000.000 butir/bulan atau 24.000.000 butir per kuartal 3 bulan) yang harus dipenuhi secara stabil dan berkesinambungan.
 </a:t>
             </a:r>
             <a:pPr indent="0" marL="0">
               <a:buNone/>
             </a:pPr>
             <a:r>
-              <a:rPr lang="en-US" sz="950" dirty="0">
+              <a:rPr lang="en-US" sz="950" b="1" dirty="0">
+                <a:solidFill>
+                  <a:srgbClr val="047857"/>
+                </a:solidFill>
+                <a:latin typeface="Arial" pitchFamily="34" charset="0"/>
+                <a:ea typeface="Arial" pitchFamily="34" charset="-122"/>
+                <a:cs typeface="Arial" pitchFamily="34" charset="-120"/>
+              </a:rPr>
+              <a:t>• Kebutuhan Perusahaan: Supply dari Perkebunan TMC (10% Target Harian): </a:t>
+            </a:r>
+            <a:pPr indent="0" marL="0">
+              <a:buNone/>
+            </a:pPr>
+            <a:r>
+              <a:rPr lang="en-US" sz="850" dirty="0">
                 <a:solidFill>
                   <a:srgbClr val="334155"/>
                 </a:solidFill>
@@ -1846,27 +1902,84 @@
                 <a:ea typeface="Arial" pitchFamily="34" charset="-122"/>
                 <a:cs typeface="Arial" pitchFamily="34" charset="-120"/>
               </a:rPr>
-              <a:t>• Target pemenuhan bahan baku operasional pabrik kelapa terpadu TMC ditetapkan sebesar </a:t>
+              <a:t>Perusahaan menetapkan pemenuhan pasokan dari kebun internal sebesar </a:t>
             </a:r>
             <a:pPr indent="0" marL="0">
               <a:buNone/>
             </a:pPr>
             <a:r>
+              <a:rPr lang="en-US" sz="850" b="1" dirty="0">
+                <a:solidFill>
+                  <a:srgbClr val="047857"/>
+                </a:solidFill>
+                <a:latin typeface="Arial" pitchFamily="34" charset="0"/>
+                <a:ea typeface="Arial" pitchFamily="34" charset="-122"/>
+                <a:cs typeface="Arial" pitchFamily="34" charset="-120"/>
+              </a:rPr>
+              <a:t>10% per hari (40.000 butir/hari kerja atau 2.400.000 butir per kuartal 3 bulan) </a:t>
+            </a:r>
+            <a:pPr indent="0" marL="0">
+              <a:buNone/>
+            </a:pPr>
+            <a:r>
+              <a:rPr lang="en-US" sz="850" dirty="0">
+                <a:solidFill>
+                  <a:srgbClr val="334155"/>
+                </a:solidFill>
+                <a:latin typeface="Arial" pitchFamily="34" charset="0"/>
+                <a:ea typeface="Arial" pitchFamily="34" charset="-122"/>
+                <a:cs typeface="Arial" pitchFamily="34" charset="-120"/>
+              </a:rPr>
+              <a:t>guna menjaga stabilitas HPP serta menjamin buffer stock operasional pabrik.
+</a:t>
+            </a:r>
+            <a:pPr indent="0" marL="0">
+              <a:buNone/>
+            </a:pPr>
+            <a:r>
               <a:rPr lang="en-US" sz="950" b="1" dirty="0">
                 <a:solidFill>
+                  <a:srgbClr val="047857"/>
+                </a:solidFill>
+                <a:latin typeface="Arial" pitchFamily="34" charset="0"/>
+                <a:ea typeface="Arial" pitchFamily="34" charset="-122"/>
+                <a:cs typeface="Arial" pitchFamily="34" charset="-120"/>
+              </a:rPr>
+              <a:t>• Realisasi Saat Ini - Perkebunan TMC Eksisting (Blok 1): </a:t>
+            </a:r>
+            <a:pPr indent="0" marL="0">
+              <a:buNone/>
+            </a:pPr>
+            <a:r>
+              <a:rPr lang="en-US" sz="850" dirty="0">
+                <a:solidFill>
+                  <a:srgbClr val="334155"/>
+                </a:solidFill>
+                <a:latin typeface="Arial" pitchFamily="34" charset="0"/>
+                <a:ea typeface="Arial" pitchFamily="34" charset="-122"/>
+                <a:cs typeface="Arial" pitchFamily="34" charset="-120"/>
+              </a:rPr>
+              <a:t>Sesuai hasil panen saat ini di seluruh kebun produktif TMC (Blok 1 seluas 200 Ha), produksi per kuartal (3 bulan) telah mencapai </a:t>
+            </a:r>
+            <a:pPr indent="0" marL="0">
+              <a:buNone/>
+            </a:pPr>
+            <a:r>
+              <a:rPr lang="en-US" sz="850" b="1" dirty="0">
+                <a:solidFill>
                   <a:srgbClr val="0F172A"/>
                 </a:solidFill>
                 <a:latin typeface="Arial" pitchFamily="34" charset="0"/>
                 <a:ea typeface="Arial" pitchFamily="34" charset="-122"/>
                 <a:cs typeface="Arial" pitchFamily="34" charset="-120"/>
               </a:rPr>
-              <a:t>8.000.000 butir/bulan (24.000.000 butir per 3 bulan / 96.000.000 butir/tahun)</a:t>
+              <a:t>hampir 200.000 butir kelapa (3.333 butir/HK). </a:t>
             </a:r>
             <a:pPr indent="0" marL="0">
               <a:buNone/>
             </a:pPr>
             <a:r>
-              <a:rPr lang="en-US" sz="950" dirty="0">
+              <a:rPr lang="en-US" sz="850" dirty="0">
                 <a:solidFill>
                   <a:srgbClr val="334155"/>
                 </a:solidFill>
@@ -1874,66 +1987,9 @@
                 <a:ea typeface="Arial" pitchFamily="34" charset="-122"/>
                 <a:cs typeface="Arial" pitchFamily="34" charset="-120"/>
               </a:rPr>
-              <a:t> dengan operasional 20 Hari Kerja/bulan (400.000 butir/HK). Angka ini adalah target kebutuhan bahan baku untuk kelancaran pabrik (bukan kapasitas olah yang telah berjalan saat ini).
-</a:t>
-            </a:r>
-            <a:pPr indent="0" marL="0">
-              <a:buNone/>
-            </a:pPr>
-            <a:r>
-              <a:rPr lang="en-US" sz="950" b="1" dirty="0">
-                <a:solidFill>
-                  <a:srgbClr val="047857"/>
-                </a:solidFill>
-                <a:latin typeface="Arial" pitchFamily="34" charset="0"/>
-                <a:ea typeface="Arial" pitchFamily="34" charset="-122"/>
-                <a:cs typeface="Arial" pitchFamily="34" charset="-120"/>
-              </a:rPr>
-              <a:t>• Mandat Kebijakan Direksi: </a:t>
-            </a:r>
-            <a:pPr indent="0" marL="0">
-              <a:buNone/>
-            </a:pPr>
-            <a:r>
-              <a:rPr lang="en-US" sz="950" dirty="0">
-                <a:solidFill>
-                  <a:srgbClr val="334155"/>
-                </a:solidFill>
-                <a:latin typeface="Arial" pitchFamily="34" charset="0"/>
-                <a:ea typeface="Arial" pitchFamily="34" charset="-122"/>
-                <a:cs typeface="Arial" pitchFamily="34" charset="-120"/>
-              </a:rPr>
-              <a:t>Menetapkan target pasokan mandiri sebesar </a:t>
-            </a:r>
-            <a:pPr indent="0" marL="0">
-              <a:buNone/>
-            </a:pPr>
-            <a:r>
-              <a:rPr lang="en-US" sz="950" b="1" dirty="0">
-                <a:solidFill>
-                  <a:srgbClr val="047857"/>
-                </a:solidFill>
-                <a:latin typeface="Arial" pitchFamily="34" charset="0"/>
-                <a:ea typeface="Arial" pitchFamily="34" charset="-122"/>
-                <a:cs typeface="Arial" pitchFamily="34" charset="-120"/>
-              </a:rPr>
-              <a:t>10% (2.400.000 butir / 3 bulan atau 40.000 butir / HK) </a:t>
-            </a:r>
-            <a:pPr indent="0" marL="0">
-              <a:buNone/>
-            </a:pPr>
-            <a:r>
-              <a:rPr lang="en-US" sz="950" dirty="0">
-                <a:solidFill>
-                  <a:srgbClr val="334155"/>
-                </a:solidFill>
-                <a:latin typeface="Arial" pitchFamily="34" charset="0"/>
-                <a:ea typeface="Arial" pitchFamily="34" charset="-122"/>
-                <a:cs typeface="Arial" pitchFamily="34" charset="-120"/>
-              </a:rPr>
-              <a:t>guna menjamin buffer stock, menstabilkan HPP, serta melindungi pabrik dari fluktuasi harga dan kelangkaan bahan baku di pasar bebas.</a:t>
-            </a:r>
-            <a:endParaRPr lang="en-US" sz="1100" dirty="0"/>
+              <a:t>Hasil ini telah menutup 8,33% kebutuhan supply kebun internal (0,83% kebutuhan produksi pabrik), sehingga sisa kebutuhan sebesar 2.200.000 butir/kuartal diselesaikan melalui ekspansi lahan baru.</a:t>
+            </a:r>
+            <a:endParaRPr lang="en-US" sz="950" dirty="0"/>
           </a:p>
         </p:txBody>
       </p:sp>
@@ -1945,12 +2001,12 @@
         </p:nvSpPr>
         <p:spPr>
           <a:xfrm>
-            <a:off x="731520" y="2971800"/>
-            <a:ext cx="2514600" cy="1463040"/>
+            <a:off x="731520" y="3017520"/>
+            <a:ext cx="2514600" cy="1417320"/>
           </a:xfrm>
           <a:prstGeom prst="roundRect">
             <a:avLst>
-              <a:gd name="adj" fmla="val 5000"/>
+              <a:gd name="adj" fmla="val 5161"/>
             </a:avLst>
           </a:prstGeom>
           <a:solidFill>
@@ -1972,8 +2028,8 @@
         </p:nvSpPr>
         <p:spPr>
           <a:xfrm>
-            <a:off x="868680" y="3127248"/>
-            <a:ext cx="2240280" cy="320040"/>
+            <a:off x="868680" y="3154680"/>
+            <a:ext cx="2240280" cy="292608"/>
           </a:xfrm>
           <a:prstGeom prst="rect">
             <a:avLst/>
@@ -1997,7 +2053,7 @@
                 <a:ea typeface="Arial" pitchFamily="34" charset="-122"/>
                 <a:cs typeface="Arial" pitchFamily="34" charset="-120"/>
               </a:rPr>
-              <a:t>KEBUTUHAN PABRIK (3 BLN)</a:t>
+              <a:t>TARGET PRODUKSI PABRIK</a:t>
             </a:r>
             <a:endParaRPr lang="en-US" sz="800" dirty="0"/>
           </a:p>
@@ -2012,7 +2068,7 @@
         <p:spPr>
           <a:xfrm>
             <a:off x="868680" y="3493008"/>
-            <a:ext cx="2240280" cy="502920"/>
+            <a:ext cx="2240280" cy="475488"/>
           </a:xfrm>
           <a:prstGeom prst="rect">
             <a:avLst/>
@@ -2028,7 +2084,7 @@
               <a:buNone/>
             </a:pPr>
             <a:r>
-              <a:rPr lang="en-US" sz="1600" b="1" dirty="0">
+              <a:rPr lang="en-US" sz="1500" b="1" dirty="0">
                 <a:solidFill>
                   <a:srgbClr val="0F172A"/>
                 </a:solidFill>
@@ -2036,9 +2092,9 @@
                 <a:ea typeface="Arial" pitchFamily="34" charset="-122"/>
                 <a:cs typeface="Arial" pitchFamily="34" charset="-120"/>
               </a:rPr>
-              <a:t>24.000.000</a:t>
-            </a:r>
-            <a:endParaRPr lang="en-US" sz="1600" dirty="0"/>
+              <a:t>400.000</a:t>
+            </a:r>
+            <a:endParaRPr lang="en-US" sz="1500" dirty="0"/>
           </a:p>
         </p:txBody>
       </p:sp>
@@ -2050,7 +2106,7 @@
         </p:nvSpPr>
         <p:spPr>
           <a:xfrm>
-            <a:off x="868680" y="4023360"/>
+            <a:off x="868680" y="4005072"/>
             <a:ext cx="2240280" cy="274320"/>
           </a:xfrm>
           <a:prstGeom prst="rect">
@@ -2067,7 +2123,7 @@
               <a:buNone/>
             </a:pPr>
             <a:r>
-              <a:rPr lang="en-US" sz="800" dirty="0">
+              <a:rPr lang="en-US" sz="750" dirty="0">
                 <a:solidFill>
                   <a:srgbClr val="334155"/>
                 </a:solidFill>
@@ -2075,9 +2131,9 @@
                 <a:ea typeface="Arial" pitchFamily="34" charset="-122"/>
                 <a:cs typeface="Arial" pitchFamily="34" charset="-120"/>
               </a:rPr>
-              <a:t>400.000 Butir / HK</a:t>
-            </a:r>
-            <a:endParaRPr lang="en-US" sz="800" dirty="0"/>
+              <a:t>Butir/Hari (24 Juta/3 Bln)</a:t>
+            </a:r>
+            <a:endParaRPr lang="en-US" sz="750" dirty="0"/>
           </a:p>
         </p:txBody>
       </p:sp>
@@ -2089,12 +2145,12 @@
         </p:nvSpPr>
         <p:spPr>
           <a:xfrm>
-            <a:off x="3456432" y="2971800"/>
-            <a:ext cx="2514600" cy="1463040"/>
+            <a:off x="3456432" y="3017520"/>
+            <a:ext cx="2514600" cy="1417320"/>
           </a:xfrm>
           <a:prstGeom prst="roundRect">
             <a:avLst>
-              <a:gd name="adj" fmla="val 5000"/>
+              <a:gd name="adj" fmla="val 5161"/>
             </a:avLst>
           </a:prstGeom>
           <a:solidFill>
@@ -2116,8 +2172,8 @@
         </p:nvSpPr>
         <p:spPr>
           <a:xfrm>
-            <a:off x="3593592" y="3127248"/>
-            <a:ext cx="2240280" cy="320040"/>
+            <a:off x="3593592" y="3154680"/>
+            <a:ext cx="2240280" cy="292608"/>
           </a:xfrm>
           <a:prstGeom prst="rect">
             <a:avLst/>
@@ -2141,7 +2197,7 @@
                 <a:ea typeface="Arial" pitchFamily="34" charset="-122"/>
                 <a:cs typeface="Arial" pitchFamily="34" charset="-120"/>
               </a:rPr>
-              <a:t>TARGET KEBUN MANDIRI (10%)</a:t>
+              <a:t>TARGET SUPPLY KEBUN (10%)</a:t>
             </a:r>
             <a:endParaRPr lang="en-US" sz="800" dirty="0"/>
           </a:p>
@@ -2156,7 +2212,7 @@
         <p:spPr>
           <a:xfrm>
             <a:off x="3593592" y="3493008"/>
-            <a:ext cx="2240280" cy="502920"/>
+            <a:ext cx="2240280" cy="475488"/>
           </a:xfrm>
           <a:prstGeom prst="rect">
             <a:avLst/>
@@ -2172,7 +2228,7 @@
               <a:buNone/>
             </a:pPr>
             <a:r>
-              <a:rPr lang="en-US" sz="1600" b="1" dirty="0">
+              <a:rPr lang="en-US" sz="1500" b="1" dirty="0">
                 <a:solidFill>
                   <a:srgbClr val="047857"/>
                 </a:solidFill>
@@ -2180,9 +2236,9 @@
                 <a:ea typeface="Arial" pitchFamily="34" charset="-122"/>
                 <a:cs typeface="Arial" pitchFamily="34" charset="-120"/>
               </a:rPr>
-              <a:t>2.400.000</a:t>
-            </a:r>
-            <a:endParaRPr lang="en-US" sz="1600" dirty="0"/>
+              <a:t>40.000</a:t>
+            </a:r>
+            <a:endParaRPr lang="en-US" sz="1500" dirty="0"/>
           </a:p>
         </p:txBody>
       </p:sp>
@@ -2194,7 +2250,7 @@
         </p:nvSpPr>
         <p:spPr>
           <a:xfrm>
-            <a:off x="3593592" y="4023360"/>
+            <a:off x="3593592" y="4005072"/>
             <a:ext cx="2240280" cy="274320"/>
           </a:xfrm>
           <a:prstGeom prst="rect">
@@ -2211,7 +2267,7 @@
               <a:buNone/>
             </a:pPr>
             <a:r>
-              <a:rPr lang="en-US" sz="800" dirty="0">
+              <a:rPr lang="en-US" sz="750" dirty="0">
                 <a:solidFill>
                   <a:srgbClr val="334155"/>
                 </a:solidFill>
@@ -2219,9 +2275,9 @@
                 <a:ea typeface="Arial" pitchFamily="34" charset="-122"/>
                 <a:cs typeface="Arial" pitchFamily="34" charset="-120"/>
               </a:rPr>
-              <a:t>40.000 Butir / HK</a:t>
-            </a:r>
-            <a:endParaRPr lang="en-US" sz="800" dirty="0"/>
+              <a:t>Butir/Hari (2,4 Juta/3 Bln)</a:t>
+            </a:r>
+            <a:endParaRPr lang="en-US" sz="750" dirty="0"/>
           </a:p>
         </p:txBody>
       </p:sp>
@@ -2233,12 +2289,156 @@
         </p:nvSpPr>
         <p:spPr>
           <a:xfrm>
-            <a:off x="6181344" y="2971800"/>
-            <a:ext cx="2514600" cy="1463040"/>
+            <a:off x="6181344" y="3017520"/>
+            <a:ext cx="2514600" cy="1417320"/>
           </a:xfrm>
           <a:prstGeom prst="roundRect">
             <a:avLst>
-              <a:gd name="adj" fmla="val 5000"/>
+              <a:gd name="adj" fmla="val 5161"/>
+            </a:avLst>
+          </a:prstGeom>
+          <a:solidFill>
+            <a:srgbClr val="F8FAFC"/>
+          </a:solidFill>
+          <a:ln w="19050">
+            <a:solidFill>
+              <a:srgbClr val="CBD5E1"/>
+            </a:solidFill>
+            <a:prstDash val="solid"/>
+          </a:ln>
+        </p:spPr>
+      </p:sp>
+      <p:sp>
+        <p:nvSpPr>
+          <p:cNvPr id="16" name="Text 14"/>
+          <p:cNvSpPr/>
+          <p:nvPr/>
+        </p:nvSpPr>
+        <p:spPr>
+          <a:xfrm>
+            <a:off x="6318504" y="3154680"/>
+            <a:ext cx="2240280" cy="292608"/>
+          </a:xfrm>
+          <a:prstGeom prst="rect">
+            <a:avLst/>
+          </a:prstGeom>
+          <a:noFill/>
+          <a:ln/>
+        </p:spPr>
+        <p:txBody>
+          <a:bodyPr wrap="square" rtlCol="0" anchor="ctr"/>
+          <a:lstStyle/>
+          <a:p>
+            <a:pPr algn="ctr" indent="0" marL="0">
+              <a:buNone/>
+            </a:pPr>
+            <a:r>
+              <a:rPr lang="en-US" sz="800" b="1" dirty="0">
+                <a:solidFill>
+                  <a:srgbClr val="64748B"/>
+                </a:solidFill>
+                <a:latin typeface="Arial" pitchFamily="34" charset="0"/>
+                <a:ea typeface="Arial" pitchFamily="34" charset="-122"/>
+                <a:cs typeface="Arial" pitchFamily="34" charset="-120"/>
+              </a:rPr>
+              <a:t>HASIL SAAT INI (BLOK 1)</a:t>
+            </a:r>
+            <a:endParaRPr lang="en-US" sz="800" dirty="0"/>
+          </a:p>
+        </p:txBody>
+      </p:sp>
+      <p:sp>
+        <p:nvSpPr>
+          <p:cNvPr id="17" name="Text 15"/>
+          <p:cNvSpPr/>
+          <p:nvPr/>
+        </p:nvSpPr>
+        <p:spPr>
+          <a:xfrm>
+            <a:off x="6318504" y="3493008"/>
+            <a:ext cx="2240280" cy="475488"/>
+          </a:xfrm>
+          <a:prstGeom prst="rect">
+            <a:avLst/>
+          </a:prstGeom>
+          <a:noFill/>
+          <a:ln/>
+        </p:spPr>
+        <p:txBody>
+          <a:bodyPr wrap="square" rtlCol="0" anchor="ctr"/>
+          <a:lstStyle/>
+          <a:p>
+            <a:pPr algn="ctr" indent="0" marL="0">
+              <a:buNone/>
+            </a:pPr>
+            <a:r>
+              <a:rPr lang="en-US" sz="1500" b="1" dirty="0">
+                <a:solidFill>
+                  <a:srgbClr val="0F172A"/>
+                </a:solidFill>
+                <a:latin typeface="Arial" pitchFamily="34" charset="0"/>
+                <a:ea typeface="Arial" pitchFamily="34" charset="-122"/>
+                <a:cs typeface="Arial" pitchFamily="34" charset="-120"/>
+              </a:rPr>
+              <a:t>~200.000</a:t>
+            </a:r>
+            <a:endParaRPr lang="en-US" sz="1500" dirty="0"/>
+          </a:p>
+        </p:txBody>
+      </p:sp>
+      <p:sp>
+        <p:nvSpPr>
+          <p:cNvPr id="18" name="Text 16"/>
+          <p:cNvSpPr/>
+          <p:nvPr/>
+        </p:nvSpPr>
+        <p:spPr>
+          <a:xfrm>
+            <a:off x="6318504" y="4005072"/>
+            <a:ext cx="2240280" cy="274320"/>
+          </a:xfrm>
+          <a:prstGeom prst="rect">
+            <a:avLst/>
+          </a:prstGeom>
+          <a:noFill/>
+          <a:ln/>
+        </p:spPr>
+        <p:txBody>
+          <a:bodyPr wrap="square" rtlCol="0" anchor="ctr"/>
+          <a:lstStyle/>
+          <a:p>
+            <a:pPr algn="ctr" indent="0" marL="0">
+              <a:buNone/>
+            </a:pPr>
+            <a:r>
+              <a:rPr lang="en-US" sz="750" dirty="0">
+                <a:solidFill>
+                  <a:srgbClr val="334155"/>
+                </a:solidFill>
+                <a:latin typeface="Arial" pitchFamily="34" charset="0"/>
+                <a:ea typeface="Arial" pitchFamily="34" charset="-122"/>
+                <a:cs typeface="Arial" pitchFamily="34" charset="-120"/>
+              </a:rPr>
+              <a:t>Butir/3 Bln (3.333 Btr/HK)</a:t>
+            </a:r>
+            <a:endParaRPr lang="en-US" sz="750" dirty="0"/>
+          </a:p>
+        </p:txBody>
+      </p:sp>
+      <p:sp>
+        <p:nvSpPr>
+          <p:cNvPr id="19" name="Shape 17"/>
+          <p:cNvSpPr/>
+          <p:nvPr/>
+        </p:nvSpPr>
+        <p:spPr>
+          <a:xfrm>
+            <a:off x="8906256" y="3017520"/>
+            <a:ext cx="2514600" cy="1417320"/>
+          </a:xfrm>
+          <a:prstGeom prst="roundRect">
+            <a:avLst>
+              <a:gd name="adj" fmla="val 5161"/>
             </a:avLst>
           </a:prstGeom>
           <a:solidFill>
@@ -2254,14 +2454,14 @@
       </p:sp>
       <p:sp>
         <p:nvSpPr>
-          <p:cNvPr id="16" name="Text 14"/>
-          <p:cNvSpPr/>
-          <p:nvPr/>
-        </p:nvSpPr>
-        <p:spPr>
-          <a:xfrm>
-            <a:off x="6318504" y="3127248"/>
-            <a:ext cx="2240280" cy="320040"/>
+          <p:cNvPr id="20" name="Text 18"/>
+          <p:cNvSpPr/>
+          <p:nvPr/>
+        </p:nvSpPr>
+        <p:spPr>
+          <a:xfrm>
+            <a:off x="9043416" y="3154680"/>
+            <a:ext cx="2240280" cy="292608"/>
           </a:xfrm>
           <a:prstGeom prst="rect">
             <a:avLst/>
@@ -2285,7 +2485,7 @@
                 <a:ea typeface="Arial" pitchFamily="34" charset="-122"/>
                 <a:cs typeface="Arial" pitchFamily="34" charset="-120"/>
               </a:rPr>
-              <a:t>REALISASI 3 BLOK KEBUN</a:t>
+              <a:t>PORTOFOLIO 3 BLOK KEBUN</a:t>
             </a:r>
             <a:endParaRPr lang="en-US" sz="800" dirty="0"/>
           </a:p>
@@ -2293,14 +2493,14 @@
       </p:sp>
       <p:sp>
         <p:nvSpPr>
-          <p:cNvPr id="17" name="Text 15"/>
-          <p:cNvSpPr/>
-          <p:nvPr/>
-        </p:nvSpPr>
-        <p:spPr>
-          <a:xfrm>
-            <a:off x="6318504" y="3493008"/>
-            <a:ext cx="2240280" cy="502920"/>
+          <p:cNvPr id="21" name="Text 19"/>
+          <p:cNvSpPr/>
+          <p:nvPr/>
+        </p:nvSpPr>
+        <p:spPr>
+          <a:xfrm>
+            <a:off x="9043416" y="3493008"/>
+            <a:ext cx="2240280" cy="475488"/>
           </a:xfrm>
           <a:prstGeom prst="rect">
             <a:avLst/>
@@ -2316,7 +2516,7 @@
               <a:buNone/>
             </a:pPr>
             <a:r>
-              <a:rPr lang="en-US" sz="1600" b="1" dirty="0">
+              <a:rPr lang="en-US" sz="1500" b="1" dirty="0">
                 <a:solidFill>
                   <a:srgbClr val="047857"/>
                 </a:solidFill>
@@ -2326,19 +2526,19 @@
               </a:rPr>
               <a:t>2.400.600</a:t>
             </a:r>
-            <a:endParaRPr lang="en-US" sz="1600" dirty="0"/>
-          </a:p>
-        </p:txBody>
-      </p:sp>
-      <p:sp>
-        <p:nvSpPr>
-          <p:cNvPr id="18" name="Text 16"/>
-          <p:cNvSpPr/>
-          <p:nvPr/>
-        </p:nvSpPr>
-        <p:spPr>
-          <a:xfrm>
-            <a:off x="6318504" y="4023360"/>
+            <a:endParaRPr lang="en-US" sz="1500" dirty="0"/>
+          </a:p>
+        </p:txBody>
+      </p:sp>
+      <p:sp>
+        <p:nvSpPr>
+          <p:cNvPr id="22" name="Text 20"/>
+          <p:cNvSpPr/>
+          <p:nvPr/>
+        </p:nvSpPr>
+        <p:spPr>
+          <a:xfrm>
+            <a:off x="9043416" y="4005072"/>
             <a:ext cx="2240280" cy="274320"/>
           </a:xfrm>
           <a:prstGeom prst="rect">
@@ -2355,7 +2555,7 @@
               <a:buNone/>
             </a:pPr>
             <a:r>
-              <a:rPr lang="en-US" sz="800" dirty="0">
+              <a:rPr lang="en-US" sz="750" dirty="0">
                 <a:solidFill>
                   <a:srgbClr val="334155"/>
                 </a:solidFill>
@@ -2363,153 +2563,9 @@
                 <a:ea typeface="Arial" pitchFamily="34" charset="-122"/>
                 <a:cs typeface="Arial" pitchFamily="34" charset="-120"/>
               </a:rPr>
-              <a:t>40.010 Butir / HK (100,03%)</a:t>
-            </a:r>
-            <a:endParaRPr lang="en-US" sz="800" dirty="0"/>
-          </a:p>
-        </p:txBody>
-      </p:sp>
-      <p:sp>
-        <p:nvSpPr>
-          <p:cNvPr id="19" name="Shape 17"/>
-          <p:cNvSpPr/>
-          <p:nvPr/>
-        </p:nvSpPr>
-        <p:spPr>
-          <a:xfrm>
-            <a:off x="8906256" y="2971800"/>
-            <a:ext cx="2514600" cy="1463040"/>
-          </a:xfrm>
-          <a:prstGeom prst="roundRect">
-            <a:avLst>
-              <a:gd name="adj" fmla="val 5000"/>
-            </a:avLst>
-          </a:prstGeom>
-          <a:solidFill>
-            <a:srgbClr val="FFFBEB"/>
-          </a:solidFill>
-          <a:ln w="19050">
-            <a:solidFill>
-              <a:srgbClr val="FDE68A"/>
-            </a:solidFill>
-            <a:prstDash val="solid"/>
-          </a:ln>
-        </p:spPr>
-      </p:sp>
-      <p:sp>
-        <p:nvSpPr>
-          <p:cNvPr id="20" name="Text 18"/>
-          <p:cNvSpPr/>
-          <p:nvPr/>
-        </p:nvSpPr>
-        <p:spPr>
-          <a:xfrm>
-            <a:off x="9043416" y="3127248"/>
-            <a:ext cx="2240280" cy="320040"/>
-          </a:xfrm>
-          <a:prstGeom prst="rect">
-            <a:avLst/>
-          </a:prstGeom>
-          <a:noFill/>
-          <a:ln/>
-        </p:spPr>
-        <p:txBody>
-          <a:bodyPr wrap="square" rtlCol="0" anchor="ctr"/>
-          <a:lstStyle/>
-          <a:p>
-            <a:pPr algn="ctr" indent="0" marL="0">
-              <a:buNone/>
-            </a:pPr>
-            <a:r>
-              <a:rPr lang="en-US" sz="800" b="1" dirty="0">
-                <a:solidFill>
-                  <a:srgbClr val="64748B"/>
-                </a:solidFill>
-                <a:latin typeface="Arial" pitchFamily="34" charset="0"/>
-                <a:ea typeface="Arial" pitchFamily="34" charset="-122"/>
-                <a:cs typeface="Arial" pitchFamily="34" charset="-120"/>
-              </a:rPr>
-              <a:t>PEMBELIAN PETANI LUAR</a:t>
-            </a:r>
-            <a:endParaRPr lang="en-US" sz="800" dirty="0"/>
-          </a:p>
-        </p:txBody>
-      </p:sp>
-      <p:sp>
-        <p:nvSpPr>
-          <p:cNvPr id="21" name="Text 19"/>
-          <p:cNvSpPr/>
-          <p:nvPr/>
-        </p:nvSpPr>
-        <p:spPr>
-          <a:xfrm>
-            <a:off x="9043416" y="3493008"/>
-            <a:ext cx="2240280" cy="502920"/>
-          </a:xfrm>
-          <a:prstGeom prst="rect">
-            <a:avLst/>
-          </a:prstGeom>
-          <a:noFill/>
-          <a:ln/>
-        </p:spPr>
-        <p:txBody>
-          <a:bodyPr wrap="square" rtlCol="0" anchor="ctr"/>
-          <a:lstStyle/>
-          <a:p>
-            <a:pPr algn="ctr" indent="0" marL="0">
-              <a:buNone/>
-            </a:pPr>
-            <a:r>
-              <a:rPr lang="en-US" sz="1600" b="1" dirty="0">
-                <a:solidFill>
-                  <a:srgbClr val="D97706"/>
-                </a:solidFill>
-                <a:latin typeface="Arial" pitchFamily="34" charset="0"/>
-                <a:ea typeface="Arial" pitchFamily="34" charset="-122"/>
-                <a:cs typeface="Arial" pitchFamily="34" charset="-120"/>
-              </a:rPr>
-              <a:t>21.599.400</a:t>
-            </a:r>
-            <a:endParaRPr lang="en-US" sz="1600" dirty="0"/>
-          </a:p>
-        </p:txBody>
-      </p:sp>
-      <p:sp>
-        <p:nvSpPr>
-          <p:cNvPr id="22" name="Text 20"/>
-          <p:cNvSpPr/>
-          <p:nvPr/>
-        </p:nvSpPr>
-        <p:spPr>
-          <a:xfrm>
-            <a:off x="9043416" y="4023360"/>
-            <a:ext cx="2240280" cy="274320"/>
-          </a:xfrm>
-          <a:prstGeom prst="rect">
-            <a:avLst/>
-          </a:prstGeom>
-          <a:noFill/>
-          <a:ln/>
-        </p:spPr>
-        <p:txBody>
-          <a:bodyPr wrap="square" rtlCol="0" anchor="ctr"/>
-          <a:lstStyle/>
-          <a:p>
-            <a:pPr algn="ctr" indent="0" marL="0">
-              <a:buNone/>
-            </a:pPr>
-            <a:r>
-              <a:rPr lang="en-US" sz="800" dirty="0">
-                <a:solidFill>
-                  <a:srgbClr val="334155"/>
-                </a:solidFill>
-                <a:latin typeface="Arial" pitchFamily="34" charset="0"/>
-                <a:ea typeface="Arial" pitchFamily="34" charset="-122"/>
-                <a:cs typeface="Arial" pitchFamily="34" charset="-120"/>
-              </a:rPr>
-              <a:t>89,99% Total Pabrik</a:t>
-            </a:r>
-            <a:endParaRPr lang="en-US" sz="800" dirty="0"/>
+              <a:t>40.010 Butir/HK (100,03%)</a:t>
+            </a:r>
+            <a:endParaRPr lang="en-US" sz="750" dirty="0"/>
           </a:p>
         </p:txBody>
       </p:sp>
@@ -2573,7 +2629,7 @@
                 <a:ea typeface="Arial" pitchFamily="34" charset="-122"/>
                 <a:cs typeface="Arial" pitchFamily="34" charset="-120"/>
               </a:rPr>
-              <a:t>Kesimpulan Latar Belakang:
+              <a:t>Kesimpulan Analisis Pasokan:
 </a:t>
             </a:r>
             <a:pPr indent="0" marL="0">
@@ -2588,7 +2644,7 @@
                 <a:ea typeface="Arial" pitchFamily="34" charset="-122"/>
                 <a:cs typeface="Arial" pitchFamily="34" charset="-120"/>
               </a:rPr>
-              <a:t>Untuk mencukupi kuota 10% pasokan (2.400.000 butir), perusahaan tidak dapat hanya mengandalkan kebun yang ada saat ini. </a:t>
+              <a:t>Realisasi panen kebun eksisting (Blok 1) yang mencapai hampir 200.000 butir per kuartal membuktikan kelayakan produktivitas kebun TMC. </a:t>
             </a:r>
             <a:pPr indent="0" marL="0">
               <a:buNone/>
@@ -2602,7 +2658,7 @@
                 <a:ea typeface="Arial" pitchFamily="34" charset="-122"/>
                 <a:cs typeface="Arial" pitchFamily="34" charset="-120"/>
               </a:rPr>
-              <a:t>Diperlukan integrasi strategis antara lahan eksisting (Blok 1), tambahan deal akuisisi (Blok 2), serta penetapan alokasi lahan ekspansi baru (Blok 3) seluas 2.044 Ha.</a:t>
+              <a:t>Guna memenuhi target supply harian 10% (40.000 butir/HK), akuisisi Blok 2 (Binjeita 135 Ha) dan pengalokasian Blok 3 (Ekspansi 2.044 Ha) secara definitif menuntaskan sisa defisit 2.200.000 butir kelapa.</a:t>
             </a:r>
             <a:endParaRPr lang="en-US" sz="1050" dirty="0"/>
           </a:p>
@@ -10942,7 +10998,7 @@
                 <a:ea typeface="Arial" pitchFamily="34" charset="-122"/>
                 <a:cs typeface="Arial" pitchFamily="34" charset="-120"/>
               </a:rPr>
-              <a:t>Mengesahkan penganggaran modal (CAPEX) untuk akuisisi/pembukaan lahan ekspansi Blok 3 seluas 2.044 Ha. Blok 3 adalah penentu utama yang menyumbang 85,17% dari target mandat 10% (2.044.000 butir/3 bulan).</a:t>
+              <a:t>Mengesahkan penganggaran modal (CAPEX) untuk akuisisi/pembukaan lahan ekspansi Blok 3 seluas 2.044 Ha. Blok 3 adalah penentu utama yang menyumbang 85,17% dari target kebutuhan supply 10% kebun TMC (2.044.000 butir/3 bulan).</a:t>
             </a:r>
             <a:endParaRPr lang="en-US" sz="850" dirty="0"/>
           </a:p>
@@ -11179,7 +11235,7 @@
                 <a:ea typeface="Arial" pitchFamily="34" charset="-122"/>
                 <a:cs typeface="Arial" pitchFamily="34" charset="-120"/>
               </a:rPr>
-              <a:t>RINGKASAN EKSEKUTIF: Portofolio 3 Blok seluas 2.379 Ha (120.030 pohon) menghasilkan 2.400.600 butir/3 bulan, TUNTAS memenuhi 100,03% dari target mandat pasokan mandiri 10% pabrik kelapa TMC.</a:t>
+              <a:t>RINGKASAN EKSEKUTIF: Portofolio 3 Blok seluas 2.379 Ha (120.030 pohon) menghasilkan 2.400.600 butir/3 bulan, TUNTAS memenuhi 100% kebutuhan supply perkebunan TMC (10% target harian produksi pabrik 400.000 butir kelapa/hari).</a:t>
             </a:r>
             <a:endParaRPr lang="en-US" sz="850" dirty="0"/>
           </a:p>

</xml_diff>

<commit_message>
chore: perbarui teks footer menjadi PERKEBUNAN TMC (MEMBER OF RAI)
</commit_message>
<xml_diff>
--- a/PAPARAN_ESTIMASI_STRATEGIS_PORTOFOLIO_KEBUN_TMC.pptx
+++ b/PAPARAN_ESTIMASI_STRATEGIS_PORTOFOLIO_KEBUN_TMC.pptx
@@ -1631,7 +1631,7 @@
               <a:buNone/>
             </a:pPr>
             <a:r>
-              <a:rPr lang="en-US" sz="850" dirty="0">
+              <a:rPr lang="en-US" sz="900" b="1" dirty="0">
                 <a:solidFill>
                   <a:srgbClr val="6EE7B7"/>
                 </a:solidFill>
@@ -1639,9 +1639,9 @@
                 <a:ea typeface="Arial" pitchFamily="34" charset="-122"/>
                 <a:cs typeface="Arial" pitchFamily="34" charset="-120"/>
               </a:rPr>
-              <a:t>PT TRI MUSTIKA CEMERLANG • DIVISI ESTIMASI &amp; PENGEMBANGAN LAHAN</a:t>
-            </a:r>
-            <a:endParaRPr lang="en-US" sz="850" dirty="0"/>
+              <a:t>PERKEBUNAN TMC (MEMBER OF RAI)</a:t>
+            </a:r>
+            <a:endParaRPr lang="en-US" sz="900" dirty="0"/>
           </a:p>
         </p:txBody>
       </p:sp>
@@ -2689,7 +2689,7 @@
               <a:buNone/>
             </a:pPr>
             <a:r>
-              <a:rPr lang="en-US" sz="800" dirty="0">
+              <a:rPr lang="en-US" sz="850" b="1" dirty="0">
                 <a:solidFill>
                   <a:srgbClr val="64748B"/>
                 </a:solidFill>
@@ -2697,9 +2697,9 @@
                 <a:ea typeface="Arial" pitchFamily="34" charset="-122"/>
                 <a:cs typeface="Arial" pitchFamily="34" charset="-120"/>
               </a:rPr>
-              <a:t>PT Tri Mustika Cemerlang (TMC) • Divisi Estimasi &amp; Pengembangan Kebun</a:t>
-            </a:r>
-            <a:endParaRPr lang="en-US" sz="800" dirty="0"/>
+              <a:t>PERKEBUNAN TMC (MEMBER OF RAI)</a:t>
+            </a:r>
+            <a:endParaRPr lang="en-US" sz="850" dirty="0"/>
           </a:p>
         </p:txBody>
       </p:sp>
@@ -5533,7 +5533,7 @@
               <a:buNone/>
             </a:pPr>
             <a:r>
-              <a:rPr lang="en-US" sz="800" dirty="0">
+              <a:rPr lang="en-US" sz="850" b="1" dirty="0">
                 <a:solidFill>
                   <a:srgbClr val="64748B"/>
                 </a:solidFill>
@@ -5541,9 +5541,9 @@
                 <a:ea typeface="Arial" pitchFamily="34" charset="-122"/>
                 <a:cs typeface="Arial" pitchFamily="34" charset="-120"/>
               </a:rPr>
-              <a:t>PT Tri Mustika Cemerlang (TMC) • Divisi Estimasi &amp; Pengembangan Kebun</a:t>
-            </a:r>
-            <a:endParaRPr lang="en-US" sz="800" dirty="0"/>
+              <a:t>PERKEBUNAN TMC (MEMBER OF RAI)</a:t>
+            </a:r>
+            <a:endParaRPr lang="en-US" sz="850" dirty="0"/>
           </a:p>
         </p:txBody>
       </p:sp>
@@ -9412,7 +9412,7 @@
               <a:buNone/>
             </a:pPr>
             <a:r>
-              <a:rPr lang="en-US" sz="800" dirty="0">
+              <a:rPr lang="en-US" sz="850" b="1" dirty="0">
                 <a:solidFill>
                   <a:srgbClr val="64748B"/>
                 </a:solidFill>
@@ -9420,9 +9420,9 @@
                 <a:ea typeface="Arial" pitchFamily="34" charset="-122"/>
                 <a:cs typeface="Arial" pitchFamily="34" charset="-120"/>
               </a:rPr>
-              <a:t>PT Tri Mustika Cemerlang (TMC) • Divisi Estimasi &amp; Pengembangan Kebun</a:t>
-            </a:r>
-            <a:endParaRPr lang="en-US" sz="800" dirty="0"/>
+              <a:t>PERKEBUNAN TMC (MEMBER OF RAI)</a:t>
+            </a:r>
+            <a:endParaRPr lang="en-US" sz="850" dirty="0"/>
           </a:p>
         </p:txBody>
       </p:sp>
@@ -10483,7 +10483,7 @@
               <a:buNone/>
             </a:pPr>
             <a:r>
-              <a:rPr lang="en-US" sz="800" dirty="0">
+              <a:rPr lang="en-US" sz="850" b="1" dirty="0">
                 <a:solidFill>
                   <a:srgbClr val="64748B"/>
                 </a:solidFill>
@@ -10491,9 +10491,9 @@
                 <a:ea typeface="Arial" pitchFamily="34" charset="-122"/>
                 <a:cs typeface="Arial" pitchFamily="34" charset="-120"/>
               </a:rPr>
-              <a:t>PT Tri Mustika Cemerlang (TMC) • Divisi Estimasi &amp; Pengembangan Kebun</a:t>
-            </a:r>
-            <a:endParaRPr lang="en-US" sz="800" dirty="0"/>
+              <a:t>PERKEBUNAN TMC (MEMBER OF RAI)</a:t>
+            </a:r>
+            <a:endParaRPr lang="en-US" sz="850" dirty="0"/>
           </a:p>
         </p:txBody>
       </p:sp>
@@ -11266,7 +11266,7 @@
               <a:buNone/>
             </a:pPr>
             <a:r>
-              <a:rPr lang="en-US" sz="800" dirty="0">
+              <a:rPr lang="en-US" sz="850" b="1" dirty="0">
                 <a:solidFill>
                   <a:srgbClr val="64748B"/>
                 </a:solidFill>
@@ -11274,9 +11274,9 @@
                 <a:ea typeface="Arial" pitchFamily="34" charset="-122"/>
                 <a:cs typeface="Arial" pitchFamily="34" charset="-120"/>
               </a:rPr>
-              <a:t>PT Tri Mustika Cemerlang (TMC) • Divisi Estimasi &amp; Pengembangan Kebun</a:t>
-            </a:r>
-            <a:endParaRPr lang="en-US" sz="800" dirty="0"/>
+              <a:t>PERKEBUNAN TMC (MEMBER OF RAI)</a:t>
+            </a:r>
+            <a:endParaRPr lang="en-US" sz="850" dirty="0"/>
           </a:p>
         </p:txBody>
       </p:sp>

</xml_diff>